<commit_message>
Add changelog, feeding parameters, and comment/footnote conventions
Introduce CHANGELOG.md and a CLAUDE.md rule to keep it updated on every
push. Parameterize Daphnia/Chaoborus feeding assumptions (individuals per
new cohort jar, max age eaten, max recorded neonates eaten) and use them
to compute Daphnia babies needed per jar per day. Scope protocol footnotes
to their own section instead of the document end, and adopt Clean Code
commenting conventions. Also carries forward pending data/figure updates
and stops tracking the stray 1_master.html generated file.

Co-Authored-By: Claude Sonnet 5 <noreply@anthropic.com>
</commit_message>
<xml_diff>
--- a/1_experiment/figures/All_figures.pptx
+++ b/1_experiment/figures/All_figures.pptx
@@ -198,7 +198,7 @@
           <a:p>
             <a:fld id="{D93E7C88-AD06-0B46-A913-FBB4EDA557A7}" type="datetimeFigureOut">
               <a:rPr lang="en-GB" smtClean="0"/>
-              <a:t>03/08/2026</a:t>
+              <a:t>04/08/2026</a:t>
             </a:fld>
             <a:endParaRPr lang="en-GB"/>
           </a:p>
@@ -845,7 +845,7 @@
           <a:p>
             <a:fld id="{6AABF641-5FF5-D94A-B89F-40D3DD45CFB8}" type="datetimeFigureOut">
               <a:rPr lang="en-GB" smtClean="0"/>
-              <a:t>03/08/2026</a:t>
+              <a:t>04/08/2026</a:t>
             </a:fld>
             <a:endParaRPr lang="en-GB"/>
           </a:p>
@@ -1045,7 +1045,7 @@
           <a:p>
             <a:fld id="{6AABF641-5FF5-D94A-B89F-40D3DD45CFB8}" type="datetimeFigureOut">
               <a:rPr lang="en-GB" smtClean="0"/>
-              <a:t>03/08/2026</a:t>
+              <a:t>04/08/2026</a:t>
             </a:fld>
             <a:endParaRPr lang="en-GB"/>
           </a:p>
@@ -1255,7 +1255,7 @@
           <a:p>
             <a:fld id="{6AABF641-5FF5-D94A-B89F-40D3DD45CFB8}" type="datetimeFigureOut">
               <a:rPr lang="en-GB" smtClean="0"/>
-              <a:t>03/08/2026</a:t>
+              <a:t>04/08/2026</a:t>
             </a:fld>
             <a:endParaRPr lang="en-GB"/>
           </a:p>
@@ -1455,7 +1455,7 @@
           <a:p>
             <a:fld id="{6AABF641-5FF5-D94A-B89F-40D3DD45CFB8}" type="datetimeFigureOut">
               <a:rPr lang="en-GB" smtClean="0"/>
-              <a:t>03/08/2026</a:t>
+              <a:t>04/08/2026</a:t>
             </a:fld>
             <a:endParaRPr lang="en-GB"/>
           </a:p>
@@ -1731,7 +1731,7 @@
           <a:p>
             <a:fld id="{6AABF641-5FF5-D94A-B89F-40D3DD45CFB8}" type="datetimeFigureOut">
               <a:rPr lang="en-GB" smtClean="0"/>
-              <a:t>03/08/2026</a:t>
+              <a:t>04/08/2026</a:t>
             </a:fld>
             <a:endParaRPr lang="en-GB"/>
           </a:p>
@@ -1999,7 +1999,7 @@
           <a:p>
             <a:fld id="{6AABF641-5FF5-D94A-B89F-40D3DD45CFB8}" type="datetimeFigureOut">
               <a:rPr lang="en-GB" smtClean="0"/>
-              <a:t>03/08/2026</a:t>
+              <a:t>04/08/2026</a:t>
             </a:fld>
             <a:endParaRPr lang="en-GB"/>
           </a:p>
@@ -2414,7 +2414,7 @@
           <a:p>
             <a:fld id="{6AABF641-5FF5-D94A-B89F-40D3DD45CFB8}" type="datetimeFigureOut">
               <a:rPr lang="en-GB" smtClean="0"/>
-              <a:t>03/08/2026</a:t>
+              <a:t>04/08/2026</a:t>
             </a:fld>
             <a:endParaRPr lang="en-GB"/>
           </a:p>
@@ -2556,7 +2556,7 @@
           <a:p>
             <a:fld id="{6AABF641-5FF5-D94A-B89F-40D3DD45CFB8}" type="datetimeFigureOut">
               <a:rPr lang="en-GB" smtClean="0"/>
-              <a:t>03/08/2026</a:t>
+              <a:t>04/08/2026</a:t>
             </a:fld>
             <a:endParaRPr lang="en-GB"/>
           </a:p>
@@ -2669,7 +2669,7 @@
           <a:p>
             <a:fld id="{6AABF641-5FF5-D94A-B89F-40D3DD45CFB8}" type="datetimeFigureOut">
               <a:rPr lang="en-GB" smtClean="0"/>
-              <a:t>03/08/2026</a:t>
+              <a:t>04/08/2026</a:t>
             </a:fld>
             <a:endParaRPr lang="en-GB"/>
           </a:p>
@@ -2982,7 +2982,7 @@
           <a:p>
             <a:fld id="{6AABF641-5FF5-D94A-B89F-40D3DD45CFB8}" type="datetimeFigureOut">
               <a:rPr lang="en-GB" smtClean="0"/>
-              <a:t>03/08/2026</a:t>
+              <a:t>04/08/2026</a:t>
             </a:fld>
             <a:endParaRPr lang="en-GB"/>
           </a:p>
@@ -3271,7 +3271,7 @@
           <a:p>
             <a:fld id="{6AABF641-5FF5-D94A-B89F-40D3DD45CFB8}" type="datetimeFigureOut">
               <a:rPr lang="en-GB" smtClean="0"/>
-              <a:t>03/08/2026</a:t>
+              <a:t>04/08/2026</a:t>
             </a:fld>
             <a:endParaRPr lang="en-GB"/>
           </a:p>
@@ -3514,7 +3514,7 @@
           <a:p>
             <a:fld id="{6AABF641-5FF5-D94A-B89F-40D3DD45CFB8}" type="datetimeFigureOut">
               <a:rPr lang="en-GB" smtClean="0"/>
-              <a:t>03/08/2026</a:t>
+              <a:t>04/08/2026</a:t>
             </a:fld>
             <a:endParaRPr lang="en-GB"/>
           </a:p>

</xml_diff>